<commit_message>
feat: harmonise les formats et centralise les jetons couleur (1.2.0)
- jetons couleur générés depuis le design system (sources/tokens.json,
  outils/generer_jetons.py) pour les thèmes SCSS, le gabarit Typst et
  les scripts Python
- PDF : texte en Marianne fournie par l'extension (plus d'avertissement
  « liberation sans »), titres en Arial, pagination après la couverture
- tableaux au modèle du PDF (en-tête indigo, lignes alternées) en Word et
  en HTML
- Word : titres comme le PDF, sans filet corail ; couleurs des titres
  rétablies (supprimées par python-docx) ; encadrés au style du PDF
- HTML : sans barre ni filet corail sur les titres, contenu élargi
- PowerPoint : tableaux numérotés rendus avec légende et renvois ;
  disposition texte puis objet en pleine largeur ; renvois en français
- workflow GitHub de rendu des cinq formats

Co-Authored-By: Claude Opus 5.5 <noreply@anthropic.com>
Claude-Session: https://claude.ai/code/session_0113azZoow6df3twQjnrUvLH
</commit_message>
<xml_diff>
--- a/_extensions/cerema/reference.pptx
+++ b/_extensions/cerema/reference.pptx
@@ -2940,8 +2940,8 @@
         </p:nvSpPr>
         <p:spPr>
           <a:xfrm>
-            <a:off x="6722269" y="1908174"/>
-            <a:ext cx="5801694" cy="4230073"/>
+            <a:off x="1190610" y="1519867"/>
+            <a:ext cx="11104000" cy="1100000"/>
           </a:xfrm>
         </p:spPr>
         <p:txBody>
@@ -3044,8 +3044,8 @@
         </p:nvSpPr>
         <p:spPr>
           <a:xfrm>
-            <a:off x="1190625" y="1343025"/>
-            <a:ext cx="4618038" cy="4795838"/>
+            <a:off x="1190610" y="2719867"/>
+            <a:ext cx="11104000" cy="3980133"/>
           </a:xfrm>
         </p:spPr>
         <p:txBody>

</xml_diff>